<commit_message>
Consolidate notebook analysis into fixed pipeline; rebuild Excel, deck and app
- churn_prediction_analysis.py: converted + fixed notebook (serial-date
  parsing, '-' masking, stale vars, seaborn deprecation, cell ordering)
- Model: one-hot logistic regression on contract, city, bundle group,
  competitors, activation year; metrics + statsmodels odds ratios saved
- Case_Study_Data_1_analysis.xlsx: adds Dashboard (charts) and Predictive
  Analytics sheets
- Churn_Analysis.pptx: rebuilt to 5 slides (descriptive charts, predictive
  tables, prescriptive analysis, insights/recommendations)
- App: calculator now uses the notebook model's feature set

Co-Authored-By: Devin AI <158243242+devin-ai-integration[bot]@users.noreply.github.com>
</commit_message>
<xml_diff>
--- a/Churn_Analysis.pptx
+++ b/Churn_Analysis.pptx
@@ -10,13 +10,8 @@
     <p:sldId id="258" r:id="rId9"/>
     <p:sldId id="259" r:id="rId10"/>
     <p:sldId id="260" r:id="rId11"/>
-    <p:sldId id="261" r:id="rId12"/>
-    <p:sldId id="262" r:id="rId13"/>
-    <p:sldId id="263" r:id="rId14"/>
-    <p:sldId id="264" r:id="rId15"/>
-    <p:sldId id="265" r:id="rId16"/>
   </p:sldIdLst>
-  <p:sldSz cx="12191695" cy="6858000" type="screen4x3"/>
+  <p:sldSz cx="12188952" cy="6858000" type="screen4x3"/>
   <p:notesSz cx="6858000" cy="9144000"/>
   <p:defaultTextStyle>
     <a:defPPr>
@@ -3105,8 +3100,8 @@
         </p:nvSpPr>
         <p:spPr>
           <a:xfrm>
-            <a:off x="457200" y="274320"/>
-            <a:ext cx="11247120" cy="822960"/>
+            <a:off x="457200" y="228600"/>
+            <a:ext cx="11247120" cy="640080"/>
           </a:xfrm>
           <a:prstGeom prst="rect">
             <a:avLst/>
@@ -3120,14 +3115,14 @@
           <a:lstStyle/>
           <a:p>
             <a:pPr>
-              <a:defRPr sz="3000" b="1">
+              <a:defRPr sz="2800" b="1">
                 <a:solidFill>
                   <a:srgbClr val="1F4E79"/>
                 </a:solidFill>
               </a:defRPr>
             </a:pPr>
             <a:r>
-              <a:t>Churn Analysis — UK Full-Fibre Broadband</a:t>
+              <a:t>Hyperoptic churn analysis — approach &amp; headline findings</a:t>
             </a:r>
           </a:p>
         </p:txBody>
@@ -3140,8 +3135,8 @@
         </p:nvSpPr>
         <p:spPr>
           <a:xfrm>
-            <a:off x="457200" y="960120"/>
-            <a:ext cx="11247120" cy="457200"/>
+            <a:off x="457200" y="1005840"/>
+            <a:ext cx="11247120" cy="5394960"/>
           </a:xfrm>
           <a:prstGeom prst="rect">
             <a:avLst/>
@@ -3149,129 +3144,6 @@
           <a:noFill/>
         </p:spPr>
         <p:txBody>
-          <a:bodyPr wrap="none">
-            <a:spAutoFit/>
-          </a:bodyPr>
-          <a:lstStyle/>
-          <a:p>
-            <a:pPr>
-              <a:defRPr sz="1500">
-                <a:solidFill>
-                  <a:srgbClr val="222222"/>
-                </a:solidFill>
-              </a:defRPr>
-            </a:pPr>
-            <a:r>
-              <a:t>Case Study Data 1 · 10,000 customers · prepared with data through Sep 2025</a:t>
-            </a:r>
-          </a:p>
-        </p:txBody>
-      </p:sp>
-      <p:sp>
-        <p:nvSpPr>
-          <p:cNvPr id="4" name="TextBox 3"/>
-          <p:cNvSpPr txBox="1"/>
-          <p:nvPr/>
-        </p:nvSpPr>
-        <p:spPr>
-          <a:xfrm>
-            <a:off x="548640" y="2926080"/>
-            <a:ext cx="10972800" cy="1828800"/>
-          </a:xfrm>
-          <a:prstGeom prst="rect">
-            <a:avLst/>
-          </a:prstGeom>
-          <a:noFill/>
-        </p:spPr>
-        <p:txBody>
-          <a:bodyPr wrap="none">
-            <a:spAutoFit/>
-          </a:bodyPr>
-          <a:lstStyle/>
-          <a:p>
-            <a:pPr>
-              <a:defRPr sz="2000">
-                <a:solidFill>
-                  <a:srgbClr val="222222"/>
-                </a:solidFill>
-              </a:defRPr>
-            </a:pPr>
-            <a:r>
-              <a:t>Understanding who leaves, why they leave, and what we can do about it.</a:t>
-            </a:r>
-          </a:p>
-        </p:txBody>
-      </p:sp>
-    </p:spTree>
-  </p:cSld>
-  <p:clrMapOvr>
-    <a:masterClrMapping/>
-  </p:clrMapOvr>
-</p:sld>
-</file>
-
-<file path=ppt/slides/slide10.xml><?xml version="1.0" encoding="utf-8"?>
-<p:sld xmlns:a="http://schemas.openxmlformats.org/drawingml/2006/main" xmlns:p="http://schemas.openxmlformats.org/presentationml/2006/main" xmlns:r="http://schemas.openxmlformats.org/officeDocument/2006/relationships">
-  <p:cSld>
-    <p:spTree>
-      <p:nvGrpSpPr>
-        <p:cNvPr id="1" name=""/>
-        <p:cNvGrpSpPr/>
-        <p:nvPr/>
-      </p:nvGrpSpPr>
-      <p:grpSpPr/>
-      <p:sp>
-        <p:nvSpPr>
-          <p:cNvPr id="2" name="TextBox 1"/>
-          <p:cNvSpPr txBox="1"/>
-          <p:nvPr/>
-        </p:nvSpPr>
-        <p:spPr>
-          <a:xfrm>
-            <a:off x="457200" y="274320"/>
-            <a:ext cx="11247120" cy="822960"/>
-          </a:xfrm>
-          <a:prstGeom prst="rect">
-            <a:avLst/>
-          </a:prstGeom>
-          <a:noFill/>
-        </p:spPr>
-        <p:txBody>
-          <a:bodyPr wrap="none">
-            <a:spAutoFit/>
-          </a:bodyPr>
-          <a:lstStyle/>
-          <a:p>
-            <a:pPr>
-              <a:defRPr sz="3000" b="1">
-                <a:solidFill>
-                  <a:srgbClr val="1F4E79"/>
-                </a:solidFill>
-              </a:defRPr>
-            </a:pPr>
-            <a:r>
-              <a:t>Caveats &amp; Next Steps</a:t>
-            </a:r>
-          </a:p>
-        </p:txBody>
-      </p:sp>
-      <p:sp>
-        <p:nvSpPr>
-          <p:cNvPr id="3" name="TextBox 2"/>
-          <p:cNvSpPr txBox="1"/>
-          <p:nvPr/>
-        </p:nvSpPr>
-        <p:spPr>
-          <a:xfrm>
-            <a:off x="548640" y="1463040"/>
-            <a:ext cx="11064240" cy="4937760"/>
-          </a:xfrm>
-          <a:prstGeom prst="rect">
-            <a:avLst/>
-          </a:prstGeom>
-          <a:noFill/>
-        </p:spPr>
-        <p:txBody>
           <a:bodyPr wrap="square">
             <a:spAutoFit/>
           </a:bodyPr>
@@ -3281,14 +3153,22 @@
               <a:spcAft>
                 <a:spcPts val="800"/>
               </a:spcAft>
-              <a:defRPr sz="1800" b="0">
+            </a:pPr>
+            <a:r>
+              <a:rPr sz="1500" b="1">
+                <a:solidFill>
+                  <a:srgbClr val="1F4E79"/>
+                </a:solidFill>
+              </a:rPr>
+              <a:t>Data</a:t>
+            </a:r>
+            <a:r>
+              <a:rPr sz="1500">
                 <a:solidFill>
                   <a:srgbClr val="222222"/>
                 </a:solidFill>
-              </a:defRPr>
-            </a:pPr>
-            <a:r>
-              <a:t>The base is churn-weighted (69.5%) — segment rates are relative, not absolute business churn</a:t>
+              </a:rPr>
+              <a:t>  —  10,000 customers · activations 2020-01–2024-12 · terminations to 2025-09. Cleaning: Excel serial dates, '-' placeholders, no duplicates, no missing outside the two termination fields.</a:t>
             </a:r>
           </a:p>
           <a:p>
@@ -3296,14 +3176,22 @@
               <a:spcAft>
                 <a:spcPts val="800"/>
               </a:spcAft>
-              <a:defRPr sz="1800" b="0">
+            </a:pPr>
+            <a:r>
+              <a:rPr sz="1500" b="1">
+                <a:solidFill>
+                  <a:srgbClr val="1F4E79"/>
+                </a:solidFill>
+              </a:rPr>
+              <a:t>Churn definition</a:t>
+            </a:r>
+            <a:r>
+              <a:rPr sz="1500">
                 <a:solidFill>
                   <a:srgbClr val="222222"/>
                 </a:solidFill>
-              </a:defRPr>
-            </a:pPr>
-            <a:r>
-              <a:t>No pricing, usage or satisfaction fields — recommended next data pull: ARPU, monthly spend, fault tickets, NPS</a:t>
+              </a:rPr>
+              <a:t>  —  recorded termination = Termination Date present (6,947 churned, 3,053 active → 69.5% of this base).</a:t>
             </a:r>
           </a:p>
           <a:p>
@@ -3311,14 +3199,91 @@
               <a:spcAft>
                 <a:spcPts val="800"/>
               </a:spcAft>
-              <a:defRPr sz="1800" b="0">
+            </a:pPr>
+            <a:r>
+              <a:rPr sz="1500" b="1">
+                <a:solidFill>
+                  <a:srgbClr val="1F4E79"/>
+                </a:solidFill>
+              </a:rPr>
+              <a:t>Headline</a:t>
+            </a:r>
+            <a:r>
+              <a:rPr sz="1500">
                 <a:solidFill>
                   <a:srgbClr val="222222"/>
                 </a:solidFill>
-              </a:defRPr>
+              </a:rPr>
+              <a:t>  —  82% of terminations are 'Moving Home/Going Away' — largely structural (customer relocates off network), not dissatisfaction.</a:t>
+            </a:r>
+          </a:p>
+          <a:p>
+            <a:pPr>
+              <a:spcAft>
+                <a:spcPts val="800"/>
+              </a:spcAft>
             </a:pPr>
             <a:r>
-              <a:t>Suggested next analyses: survival/hazard modelling by cohort, mover-destination capture rate, competitor-density heatmap by postcode district</a:t>
+              <a:rPr sz="1500" b="1">
+                <a:solidFill>
+                  <a:srgbClr val="1F4E79"/>
+                </a:solidFill>
+              </a:rPr>
+              <a:t>Strongest lever</a:t>
+            </a:r>
+            <a:r>
+              <a:rPr sz="1500">
+                <a:solidFill>
+                  <a:srgbClr val="222222"/>
+                </a:solidFill>
+              </a:rPr>
+              <a:t>  —  24-month contracts churn at 42.5% vs ~75% for monthly/12-month (odds 78% lower after controls).</a:t>
+            </a:r>
+          </a:p>
+          <a:p>
+            <a:pPr>
+              <a:spcAft>
+                <a:spcPts val="800"/>
+              </a:spcAft>
+            </a:pPr>
+            <a:r>
+              <a:rPr sz="1500" b="1">
+                <a:solidFill>
+                  <a:srgbClr val="1F4E79"/>
+                </a:solidFill>
+              </a:rPr>
+              <a:t>Geography</a:t>
+            </a:r>
+            <a:r>
+              <a:rPr sz="1500">
+                <a:solidFill>
+                  <a:srgbClr val="222222"/>
+                </a:solidFill>
+              </a:rPr>
+              <a:t>  —  Leeds 82.4% and Manchester 77.0% churn far above London 62.6% and Nottingham 41.4%.</a:t>
+            </a:r>
+          </a:p>
+          <a:p>
+            <a:pPr>
+              <a:spcAft>
+                <a:spcPts val="800"/>
+              </a:spcAft>
+            </a:pPr>
+            <a:r>
+              <a:rPr sz="1500" b="1">
+                <a:solidFill>
+                  <a:srgbClr val="1F4E79"/>
+                </a:solidFill>
+              </a:rPr>
+              <a:t>Tools</a:t>
+            </a:r>
+            <a:r>
+              <a:rPr sz="1500">
+                <a:solidFill>
+                  <a:srgbClr val="222222"/>
+                </a:solidFill>
+              </a:rPr>
+              <a:t>  —  pandas / scikit-learn / statsmodels / Chi-square &amp; Cramér's V / logistic regression / Flask dashboard.</a:t>
             </a:r>
           </a:p>
         </p:txBody>
@@ -3349,8 +3314,8 @@
         </p:nvSpPr>
         <p:spPr>
           <a:xfrm>
-            <a:off x="457200" y="274320"/>
-            <a:ext cx="11247120" cy="822960"/>
+            <a:off x="457200" y="228600"/>
+            <a:ext cx="11247120" cy="640080"/>
           </a:xfrm>
           <a:prstGeom prst="rect">
             <a:avLst/>
@@ -3364,161 +3329,114 @@
           <a:lstStyle/>
           <a:p>
             <a:pPr>
-              <a:defRPr sz="3000" b="1">
+              <a:defRPr sz="2800" b="1">
                 <a:solidFill>
                   <a:srgbClr val="1F4E79"/>
                 </a:solidFill>
               </a:defRPr>
             </a:pPr>
             <a:r>
-              <a:t>Data &amp; Approach</a:t>
-            </a:r>
-          </a:p>
-        </p:txBody>
-      </p:sp>
-      <p:sp>
-        <p:nvSpPr>
-          <p:cNvPr id="3" name="TextBox 2"/>
-          <p:cNvSpPr txBox="1"/>
+              <a:t>Descriptive analysis — where churn concentrates</a:t>
+            </a:r>
+          </a:p>
+        </p:txBody>
+      </p:sp>
+      <p:pic>
+        <p:nvPicPr>
+          <p:cNvPr id="3" name="Picture 2" descr="nb_contract_churn.png"/>
+          <p:cNvPicPr>
+            <a:picLocks noChangeAspect="1"/>
+          </p:cNvPicPr>
           <p:nvPr/>
-        </p:nvSpPr>
+        </p:nvPicPr>
+        <p:blipFill>
+          <a:blip r:embed="rId2"/>
+          <a:stretch>
+            <a:fillRect/>
+          </a:stretch>
+        </p:blipFill>
         <p:spPr>
           <a:xfrm>
-            <a:off x="548640" y="1463040"/>
-            <a:ext cx="11064240" cy="4937760"/>
+            <a:off x="365760" y="914400"/>
+            <a:ext cx="5669280" cy="3505624"/>
           </a:xfrm>
           <a:prstGeom prst="rect">
             <a:avLst/>
           </a:prstGeom>
-          <a:noFill/>
         </p:spPr>
-        <p:txBody>
-          <a:bodyPr wrap="square">
-            <a:spAutoFit/>
-          </a:bodyPr>
-          <a:lstStyle/>
-          <a:p>
-            <a:pPr>
-              <a:spcAft>
-                <a:spcPts val="800"/>
-              </a:spcAft>
-              <a:defRPr sz="1800" b="1">
-                <a:solidFill>
-                  <a:srgbClr val="222222"/>
-                </a:solidFill>
-              </a:defRPr>
-            </a:pPr>
-            <a:r>
-              <a:t>Dataset: 10,000 customers across London, Manchester, Leeds and Nottingham</a:t>
-            </a:r>
-          </a:p>
-          <a:p>
-            <a:pPr lvl="1">
-              <a:spcAft>
-                <a:spcPts val="800"/>
-              </a:spcAft>
-              <a:defRPr sz="1600" b="0">
-                <a:solidFill>
-                  <a:srgbClr val="222222"/>
-                </a:solidFill>
-              </a:defRPr>
-            </a:pPr>
-            <a:r>
-              <a:t>Fields: city, postcode, bundle speed, contract duration, competitor presence, activation/termination dates and reason</a:t>
-            </a:r>
-          </a:p>
-          <a:p>
-            <a:pPr>
-              <a:spcAft>
-                <a:spcPts val="800"/>
-              </a:spcAft>
-              <a:defRPr sz="1800" b="1">
-                <a:solidFill>
-                  <a:srgbClr val="222222"/>
-                </a:solidFill>
-              </a:defRPr>
-            </a:pPr>
-            <a:r>
-              <a:t>Cleaning performed</a:t>
-            </a:r>
-          </a:p>
-          <a:p>
-            <a:pPr lvl="1">
-              <a:spcAft>
-                <a:spcPts val="800"/>
-              </a:spcAft>
-              <a:defRPr sz="1600" b="0">
-                <a:solidFill>
-                  <a:srgbClr val="222222"/>
-                </a:solidFill>
-              </a:defRPr>
-            </a:pPr>
-            <a:r>
-              <a:t>Excel serial dates converted; termination date '-' / blank treated as still active</a:t>
-            </a:r>
-          </a:p>
-          <a:p>
-            <a:pPr lvl="1">
-              <a:spcAft>
-                <a:spcPts val="800"/>
-              </a:spcAft>
-              <a:defRPr sz="1600" b="0">
-                <a:solidFill>
-                  <a:srgbClr val="222222"/>
-                </a:solidFill>
-              </a:defRPr>
-            </a:pPr>
-            <a:r>
-              <a:t>Churn flag: has a termination date and a real termination reason → 6,947 churned, 3,053 active</a:t>
-            </a:r>
-          </a:p>
-          <a:p>
-            <a:pPr lvl="1">
-              <a:spcAft>
-                <a:spcPts val="800"/>
-              </a:spcAft>
-              <a:defRPr sz="1600" b="0">
-                <a:solidFill>
-                  <a:srgbClr val="222222"/>
-                </a:solidFill>
-              </a:defRPr>
-            </a:pPr>
-            <a:r>
-              <a:t>Tenure measured to termination (churned) or to snapshot date Sep-2025 (active)</a:t>
-            </a:r>
-          </a:p>
-          <a:p>
-            <a:pPr>
-              <a:spcAft>
-                <a:spcPts val="800"/>
-              </a:spcAft>
-              <a:defRPr sz="1800" b="1">
-                <a:solidFill>
-                  <a:srgbClr val="222222"/>
-                </a:solidFill>
-              </a:defRPr>
-            </a:pPr>
-            <a:r>
-              <a:t>Overall churn rate in the base: 69.5% — unusually high, consistent with a churn-weighted sample</a:t>
-            </a:r>
-          </a:p>
-          <a:p>
-            <a:pPr lvl="1">
-              <a:spcAft>
-                <a:spcPts val="800"/>
-              </a:spcAft>
-              <a:defRPr sz="1600" b="0">
-                <a:solidFill>
-                  <a:srgbClr val="222222"/>
-                </a:solidFill>
-              </a:defRPr>
-            </a:pPr>
-            <a:r>
-              <a:t>All findings below compare churn rates between segments, not absolute volumes</a:t>
-            </a:r>
-          </a:p>
-        </p:txBody>
-      </p:sp>
+      </p:pic>
+      <p:pic>
+        <p:nvPicPr>
+          <p:cNvPr id="4" name="Picture 3" descr="nb_city_churn.png"/>
+          <p:cNvPicPr>
+            <a:picLocks noChangeAspect="1"/>
+          </p:cNvPicPr>
+          <p:nvPr/>
+        </p:nvPicPr>
+        <p:blipFill>
+          <a:blip r:embed="rId3"/>
+          <a:stretch>
+            <a:fillRect/>
+          </a:stretch>
+        </p:blipFill>
+        <p:spPr>
+          <a:xfrm>
+            <a:off x="6217920" y="914400"/>
+            <a:ext cx="5669280" cy="3507845"/>
+          </a:xfrm>
+          <a:prstGeom prst="rect">
+            <a:avLst/>
+          </a:prstGeom>
+        </p:spPr>
+      </p:pic>
+      <p:pic>
+        <p:nvPicPr>
+          <p:cNvPr id="5" name="Picture 4" descr="nb_cohort_churn.png"/>
+          <p:cNvPicPr>
+            <a:picLocks noChangeAspect="1"/>
+          </p:cNvPicPr>
+          <p:nvPr/>
+        </p:nvPicPr>
+        <p:blipFill>
+          <a:blip r:embed="rId4"/>
+          <a:stretch>
+            <a:fillRect/>
+          </a:stretch>
+        </p:blipFill>
+        <p:spPr>
+          <a:xfrm>
+            <a:off x="365760" y="3931920"/>
+            <a:ext cx="5669280" cy="3505624"/>
+          </a:xfrm>
+          <a:prstGeom prst="rect">
+            <a:avLst/>
+          </a:prstGeom>
+        </p:spPr>
+      </p:pic>
+      <p:pic>
+        <p:nvPicPr>
+          <p:cNvPr id="6" name="Picture 5" descr="nb_bundle_churn_all.png"/>
+          <p:cNvPicPr>
+            <a:picLocks noChangeAspect="1"/>
+          </p:cNvPicPr>
+          <p:nvPr/>
+        </p:nvPicPr>
+        <p:blipFill>
+          <a:blip r:embed="rId5"/>
+          <a:stretch>
+            <a:fillRect/>
+          </a:stretch>
+        </p:blipFill>
+        <p:spPr>
+          <a:xfrm>
+            <a:off x="6217920" y="3931920"/>
+            <a:ext cx="5669280" cy="3505624"/>
+          </a:xfrm>
+          <a:prstGeom prst="rect">
+            <a:avLst/>
+          </a:prstGeom>
+        </p:spPr>
+      </p:pic>
     </p:spTree>
   </p:cSld>
   <p:clrMapOvr>
@@ -3545,8 +3463,8 @@
         </p:nvSpPr>
         <p:spPr>
           <a:xfrm>
-            <a:off x="457200" y="274320"/>
-            <a:ext cx="11247120" cy="822960"/>
+            <a:off x="457200" y="228600"/>
+            <a:ext cx="11247120" cy="640080"/>
           </a:xfrm>
           <a:prstGeom prst="rect">
             <a:avLst/>
@@ -3560,28 +3478,680 @@
           <a:lstStyle/>
           <a:p>
             <a:pPr>
-              <a:defRPr sz="3000" b="1">
+              <a:defRPr sz="2800" b="1">
                 <a:solidFill>
                   <a:srgbClr val="1F4E79"/>
                 </a:solidFill>
               </a:defRPr>
             </a:pPr>
             <a:r>
-              <a:t>Headline Findings</a:t>
-            </a:r>
-          </a:p>
-        </p:txBody>
-      </p:sp>
-      <p:sp>
-        <p:nvSpPr>
-          <p:cNvPr id="3" name="TextBox 2"/>
+              <a:t>Predictive layer — logistic regression results</a:t>
+            </a:r>
+          </a:p>
+        </p:txBody>
+      </p:sp>
+      <p:graphicFrame>
+        <p:nvGraphicFramePr>
+          <p:cNvPr id="3" name="Table 2"/>
+          <p:cNvGraphicFramePr>
+            <a:graphicFrameLocks noGrp="1"/>
+          </p:cNvGraphicFramePr>
+          <p:nvPr/>
+        </p:nvGraphicFramePr>
+        <p:xfrm>
+          <a:off x="457200" y="1005840"/>
+          <a:ext cx="5120640" cy="1737360"/>
+        </p:xfrm>
+        <a:graphic>
+          <a:graphicData uri="http://schemas.openxmlformats.org/drawingml/2006/table">
+            <a:tbl>
+              <a:tblPr firstRow="1" bandRow="1">
+                <a:tableStyleId>{5C22544A-7EE6-4342-B048-85BDC9FD1C3A}</a:tableStyleId>
+              </a:tblPr>
+              <a:tblGrid>
+                <a:gridCol w="1706880"/>
+                <a:gridCol w="1706880"/>
+                <a:gridCol w="1706880"/>
+              </a:tblGrid>
+              <a:tr h="347472">
+                <a:tc>
+                  <a:txBody>
+                    <a:bodyPr/>
+                    <a:lstStyle/>
+                    <a:p>
+                      <a:r>
+                        <a:rPr sz="1200" b="1">
+                          <a:solidFill>
+                            <a:srgbClr val="1F4E79"/>
+                          </a:solidFill>
+                        </a:rPr>
+                        <a:t>Metric</a:t>
+                      </a:r>
+                    </a:p>
+                  </a:txBody>
+                  <a:tcPr/>
+                </a:tc>
+                <a:tc>
+                  <a:txBody>
+                    <a:bodyPr/>
+                    <a:lstStyle/>
+                    <a:p>
+                      <a:r>
+                        <a:rPr sz="1200" b="1">
+                          <a:solidFill>
+                            <a:srgbClr val="1F4E79"/>
+                          </a:solidFill>
+                        </a:rPr>
+                        <a:t>Full model</a:t>
+                      </a:r>
+                    </a:p>
+                  </a:txBody>
+                  <a:tcPr/>
+                </a:tc>
+                <a:tc>
+                  <a:txBody>
+                    <a:bodyPr/>
+                    <a:lstStyle/>
+                    <a:p>
+                      <a:r>
+                        <a:rPr sz="1200" b="1">
+                          <a:solidFill>
+                            <a:srgbClr val="1F4E79"/>
+                          </a:solidFill>
+                        </a:rPr>
+                        <a:t>Without activation year</a:t>
+                      </a:r>
+                    </a:p>
+                  </a:txBody>
+                  <a:tcPr/>
+                </a:tc>
+              </a:tr>
+              <a:tr h="347472">
+                <a:tc>
+                  <a:txBody>
+                    <a:bodyPr/>
+                    <a:lstStyle/>
+                    <a:p>
+                      <a:r>
+                        <a:rPr sz="1200"/>
+                        <a:t>Accuracy</a:t>
+                      </a:r>
+                    </a:p>
+                  </a:txBody>
+                  <a:tcPr/>
+                </a:tc>
+                <a:tc>
+                  <a:txBody>
+                    <a:bodyPr/>
+                    <a:lstStyle/>
+                    <a:p>
+                      <a:r>
+                        <a:rPr sz="1200"/>
+                        <a:t>78.0%</a:t>
+                      </a:r>
+                    </a:p>
+                  </a:txBody>
+                  <a:tcPr/>
+                </a:tc>
+                <a:tc>
+                  <a:txBody>
+                    <a:bodyPr/>
+                    <a:lstStyle/>
+                    <a:p>
+                      <a:r>
+                        <a:rPr sz="1200"/>
+                        <a:t>71.6%</a:t>
+                      </a:r>
+                    </a:p>
+                  </a:txBody>
+                  <a:tcPr/>
+                </a:tc>
+              </a:tr>
+              <a:tr h="347472">
+                <a:tc>
+                  <a:txBody>
+                    <a:bodyPr/>
+                    <a:lstStyle/>
+                    <a:p>
+                      <a:r>
+                        <a:rPr sz="1200"/>
+                        <a:t>Precision</a:t>
+                      </a:r>
+                    </a:p>
+                  </a:txBody>
+                  <a:tcPr/>
+                </a:tc>
+                <a:tc>
+                  <a:txBody>
+                    <a:bodyPr/>
+                    <a:lstStyle/>
+                    <a:p>
+                      <a:r>
+                        <a:rPr sz="1200"/>
+                        <a:t>80.9%</a:t>
+                      </a:r>
+                    </a:p>
+                  </a:txBody>
+                  <a:tcPr/>
+                </a:tc>
+                <a:tc>
+                  <a:txBody>
+                    <a:bodyPr/>
+                    <a:lstStyle/>
+                    <a:p>
+                      <a:r>
+                        <a:rPr sz="1200"/>
+                        <a:t>72.9%</a:t>
+                      </a:r>
+                    </a:p>
+                  </a:txBody>
+                  <a:tcPr/>
+                </a:tc>
+              </a:tr>
+              <a:tr h="347472">
+                <a:tc>
+                  <a:txBody>
+                    <a:bodyPr/>
+                    <a:lstStyle/>
+                    <a:p>
+                      <a:r>
+                        <a:rPr sz="1200"/>
+                        <a:t>Recall</a:t>
+                      </a:r>
+                    </a:p>
+                  </a:txBody>
+                  <a:tcPr/>
+                </a:tc>
+                <a:tc>
+                  <a:txBody>
+                    <a:bodyPr/>
+                    <a:lstStyle/>
+                    <a:p>
+                      <a:r>
+                        <a:rPr sz="1200"/>
+                        <a:t>89.5%</a:t>
+                      </a:r>
+                    </a:p>
+                  </a:txBody>
+                  <a:tcPr/>
+                </a:tc>
+                <a:tc>
+                  <a:txBody>
+                    <a:bodyPr/>
+                    <a:lstStyle/>
+                    <a:p>
+                      <a:r>
+                        <a:rPr sz="1200"/>
+                        <a:t>94.0%</a:t>
+                      </a:r>
+                    </a:p>
+                  </a:txBody>
+                  <a:tcPr/>
+                </a:tc>
+              </a:tr>
+              <a:tr h="347472">
+                <a:tc>
+                  <a:txBody>
+                    <a:bodyPr/>
+                    <a:lstStyle/>
+                    <a:p>
+                      <a:r>
+                        <a:rPr sz="1200"/>
+                        <a:t>ROC-AUC</a:t>
+                      </a:r>
+                    </a:p>
+                  </a:txBody>
+                  <a:tcPr/>
+                </a:tc>
+                <a:tc>
+                  <a:txBody>
+                    <a:bodyPr/>
+                    <a:lstStyle/>
+                    <a:p>
+                      <a:r>
+                        <a:rPr sz="1200"/>
+                        <a:t>0.80</a:t>
+                      </a:r>
+                    </a:p>
+                  </a:txBody>
+                  <a:tcPr/>
+                </a:tc>
+                <a:tc>
+                  <a:txBody>
+                    <a:bodyPr/>
+                    <a:lstStyle/>
+                    <a:p>
+                      <a:r>
+                        <a:rPr sz="1200"/>
+                        <a:t>0.64</a:t>
+                      </a:r>
+                    </a:p>
+                  </a:txBody>
+                  <a:tcPr/>
+                </a:tc>
+              </a:tr>
+            </a:tbl>
+          </a:graphicData>
+        </a:graphic>
+      </p:graphicFrame>
+      <p:graphicFrame>
+        <p:nvGraphicFramePr>
+          <p:cNvPr id="4" name="Table 3"/>
+          <p:cNvGraphicFramePr>
+            <a:graphicFrameLocks noGrp="1"/>
+          </p:cNvGraphicFramePr>
+          <p:nvPr/>
+        </p:nvGraphicFramePr>
+        <p:xfrm>
+          <a:off x="6035040" y="1005840"/>
+          <a:ext cx="5669280" cy="2926080"/>
+        </p:xfrm>
+        <a:graphic>
+          <a:graphicData uri="http://schemas.openxmlformats.org/drawingml/2006/table">
+            <a:tbl>
+              <a:tblPr firstRow="1" bandRow="1">
+                <a:tableStyleId>{5C22544A-7EE6-4342-B048-85BDC9FD1C3A}</a:tableStyleId>
+              </a:tblPr>
+              <a:tblGrid>
+                <a:gridCol w="1889760"/>
+                <a:gridCol w="1889760"/>
+                <a:gridCol w="1889760"/>
+              </a:tblGrid>
+              <a:tr h="325120">
+                <a:tc>
+                  <a:txBody>
+                    <a:bodyPr/>
+                    <a:lstStyle/>
+                    <a:p>
+                      <a:r>
+                        <a:rPr sz="1200" b="1">
+                          <a:solidFill>
+                            <a:srgbClr val="1F4E79"/>
+                          </a:solidFill>
+                        </a:rPr>
+                        <a:t>Term</a:t>
+                      </a:r>
+                    </a:p>
+                  </a:txBody>
+                  <a:tcPr/>
+                </a:tc>
+                <a:tc>
+                  <a:txBody>
+                    <a:bodyPr/>
+                    <a:lstStyle/>
+                    <a:p>
+                      <a:r>
+                        <a:rPr sz="1200" b="1">
+                          <a:solidFill>
+                            <a:srgbClr val="1F4E79"/>
+                          </a:solidFill>
+                        </a:rPr>
+                        <a:t>Odds ratio</a:t>
+                      </a:r>
+                    </a:p>
+                  </a:txBody>
+                  <a:tcPr/>
+                </a:tc>
+                <a:tc>
+                  <a:txBody>
+                    <a:bodyPr/>
+                    <a:lstStyle/>
+                    <a:p>
+                      <a:r>
+                        <a:rPr sz="1200" b="1">
+                          <a:solidFill>
+                            <a:srgbClr val="1F4E79"/>
+                          </a:solidFill>
+                        </a:rPr>
+                        <a:t>p</a:t>
+                      </a:r>
+                    </a:p>
+                  </a:txBody>
+                  <a:tcPr/>
+                </a:tc>
+              </a:tr>
+              <a:tr h="325120">
+                <a:tc>
+                  <a:txBody>
+                    <a:bodyPr/>
+                    <a:lstStyle/>
+                    <a:p>
+                      <a:r>
+                        <a:rPr sz="1200"/>
+                        <a:t>Contract Type_24 Months</a:t>
+                      </a:r>
+                    </a:p>
+                  </a:txBody>
+                  <a:tcPr/>
+                </a:tc>
+                <a:tc>
+                  <a:txBody>
+                    <a:bodyPr/>
+                    <a:lstStyle/>
+                    <a:p>
+                      <a:r>
+                        <a:rPr sz="1200"/>
+                        <a:t>0.22</a:t>
+                      </a:r>
+                    </a:p>
+                  </a:txBody>
+                  <a:tcPr/>
+                </a:tc>
+                <a:tc>
+                  <a:txBody>
+                    <a:bodyPr/>
+                    <a:lstStyle/>
+                    <a:p>
+                      <a:r>
+                        <a:rPr sz="1200"/>
+                        <a:t>0.000</a:t>
+                      </a:r>
+                    </a:p>
+                  </a:txBody>
+                  <a:tcPr/>
+                </a:tc>
+              </a:tr>
+              <a:tr h="325120">
+                <a:tc>
+                  <a:txBody>
+                    <a:bodyPr/>
+                    <a:lstStyle/>
+                    <a:p>
+                      <a:r>
+                        <a:rPr sz="1200"/>
+                        <a:t>Contract Type_Monthly Rolling</a:t>
+                      </a:r>
+                    </a:p>
+                  </a:txBody>
+                  <a:tcPr/>
+                </a:tc>
+                <a:tc>
+                  <a:txBody>
+                    <a:bodyPr/>
+                    <a:lstStyle/>
+                    <a:p>
+                      <a:r>
+                        <a:rPr sz="1200"/>
+                        <a:t>1.28</a:t>
+                      </a:r>
+                    </a:p>
+                  </a:txBody>
+                  <a:tcPr/>
+                </a:tc>
+                <a:tc>
+                  <a:txBody>
+                    <a:bodyPr/>
+                    <a:lstStyle/>
+                    <a:p>
+                      <a:r>
+                        <a:rPr sz="1200"/>
+                        <a:t>0.000</a:t>
+                      </a:r>
+                    </a:p>
+                  </a:txBody>
+                  <a:tcPr/>
+                </a:tc>
+              </a:tr>
+              <a:tr h="325120">
+                <a:tc>
+                  <a:txBody>
+                    <a:bodyPr/>
+                    <a:lstStyle/>
+                    <a:p>
+                      <a:r>
+                        <a:rPr sz="1200"/>
+                        <a:t>City_Manchester</a:t>
+                      </a:r>
+                    </a:p>
+                  </a:txBody>
+                  <a:tcPr/>
+                </a:tc>
+                <a:tc>
+                  <a:txBody>
+                    <a:bodyPr/>
+                    <a:lstStyle/>
+                    <a:p>
+                      <a:r>
+                        <a:rPr sz="1200"/>
+                        <a:t>1.51</a:t>
+                      </a:r>
+                    </a:p>
+                  </a:txBody>
+                  <a:tcPr/>
+                </a:tc>
+                <a:tc>
+                  <a:txBody>
+                    <a:bodyPr/>
+                    <a:lstStyle/>
+                    <a:p>
+                      <a:r>
+                        <a:rPr sz="1200"/>
+                        <a:t>0.000</a:t>
+                      </a:r>
+                    </a:p>
+                  </a:txBody>
+                  <a:tcPr/>
+                </a:tc>
+              </a:tr>
+              <a:tr h="325120">
+                <a:tc>
+                  <a:txBody>
+                    <a:bodyPr/>
+                    <a:lstStyle/>
+                    <a:p>
+                      <a:r>
+                        <a:rPr sz="1200"/>
+                        <a:t>City_Nottingham</a:t>
+                      </a:r>
+                    </a:p>
+                  </a:txBody>
+                  <a:tcPr/>
+                </a:tc>
+                <a:tc>
+                  <a:txBody>
+                    <a:bodyPr/>
+                    <a:lstStyle/>
+                    <a:p>
+                      <a:r>
+                        <a:rPr sz="1200"/>
+                        <a:t>0.36</a:t>
+                      </a:r>
+                    </a:p>
+                  </a:txBody>
+                  <a:tcPr/>
+                </a:tc>
+                <a:tc>
+                  <a:txBody>
+                    <a:bodyPr/>
+                    <a:lstStyle/>
+                    <a:p>
+                      <a:r>
+                        <a:rPr sz="1200"/>
+                        <a:t>0.000</a:t>
+                      </a:r>
+                    </a:p>
+                  </a:txBody>
+                  <a:tcPr/>
+                </a:tc>
+              </a:tr>
+              <a:tr h="325120">
+                <a:tc>
+                  <a:txBody>
+                    <a:bodyPr/>
+                    <a:lstStyle/>
+                    <a:p>
+                      <a:r>
+                        <a:rPr sz="1200"/>
+                        <a:t>Bundle Group_50Mb</a:t>
+                      </a:r>
+                    </a:p>
+                  </a:txBody>
+                  <a:tcPr/>
+                </a:tc>
+                <a:tc>
+                  <a:txBody>
+                    <a:bodyPr/>
+                    <a:lstStyle/>
+                    <a:p>
+                      <a:r>
+                        <a:rPr sz="1200"/>
+                        <a:t>1.39</a:t>
+                      </a:r>
+                    </a:p>
+                  </a:txBody>
+                  <a:tcPr/>
+                </a:tc>
+                <a:tc>
+                  <a:txBody>
+                    <a:bodyPr/>
+                    <a:lstStyle/>
+                    <a:p>
+                      <a:r>
+                        <a:rPr sz="1200"/>
+                        <a:t>0.001</a:t>
+                      </a:r>
+                    </a:p>
+                  </a:txBody>
+                  <a:tcPr/>
+                </a:tc>
+              </a:tr>
+              <a:tr h="325120">
+                <a:tc>
+                  <a:txBody>
+                    <a:bodyPr/>
+                    <a:lstStyle/>
+                    <a:p>
+                      <a:r>
+                        <a:rPr sz="1200"/>
+                        <a:t>Bundle Group_Other</a:t>
+                      </a:r>
+                    </a:p>
+                  </a:txBody>
+                  <a:tcPr/>
+                </a:tc>
+                <a:tc>
+                  <a:txBody>
+                    <a:bodyPr/>
+                    <a:lstStyle/>
+                    <a:p>
+                      <a:r>
+                        <a:rPr sz="1200"/>
+                        <a:t>0.51</a:t>
+                      </a:r>
+                    </a:p>
+                  </a:txBody>
+                  <a:tcPr/>
+                </a:tc>
+                <a:tc>
+                  <a:txBody>
+                    <a:bodyPr/>
+                    <a:lstStyle/>
+                    <a:p>
+                      <a:r>
+                        <a:rPr sz="1200"/>
+                        <a:t>0.000</a:t>
+                      </a:r>
+                    </a:p>
+                  </a:txBody>
+                  <a:tcPr/>
+                </a:tc>
+              </a:tr>
+              <a:tr h="325120">
+                <a:tc>
+                  <a:txBody>
+                    <a:bodyPr/>
+                    <a:lstStyle/>
+                    <a:p>
+                      <a:r>
+                        <a:rPr sz="1200"/>
+                        <a:t>Activation Year_2023</a:t>
+                      </a:r>
+                    </a:p>
+                  </a:txBody>
+                  <a:tcPr/>
+                </a:tc>
+                <a:tc>
+                  <a:txBody>
+                    <a:bodyPr/>
+                    <a:lstStyle/>
+                    <a:p>
+                      <a:r>
+                        <a:rPr sz="1200"/>
+                        <a:t>0.54</a:t>
+                      </a:r>
+                    </a:p>
+                  </a:txBody>
+                  <a:tcPr/>
+                </a:tc>
+                <a:tc>
+                  <a:txBody>
+                    <a:bodyPr/>
+                    <a:lstStyle/>
+                    <a:p>
+                      <a:r>
+                        <a:rPr sz="1200"/>
+                        <a:t>0.000</a:t>
+                      </a:r>
+                    </a:p>
+                  </a:txBody>
+                  <a:tcPr/>
+                </a:tc>
+              </a:tr>
+              <a:tr h="325120">
+                <a:tc>
+                  <a:txBody>
+                    <a:bodyPr/>
+                    <a:lstStyle/>
+                    <a:p>
+                      <a:r>
+                        <a:rPr sz="1200"/>
+                        <a:t>Activation Year_2024</a:t>
+                      </a:r>
+                    </a:p>
+                  </a:txBody>
+                  <a:tcPr/>
+                </a:tc>
+                <a:tc>
+                  <a:txBody>
+                    <a:bodyPr/>
+                    <a:lstStyle/>
+                    <a:p>
+                      <a:r>
+                        <a:rPr sz="1200"/>
+                        <a:t>0.09</a:t>
+                      </a:r>
+                    </a:p>
+                  </a:txBody>
+                  <a:tcPr/>
+                </a:tc>
+                <a:tc>
+                  <a:txBody>
+                    <a:bodyPr/>
+                    <a:lstStyle/>
+                    <a:p>
+                      <a:r>
+                        <a:rPr sz="1200"/>
+                        <a:t>0.000</a:t>
+                      </a:r>
+                    </a:p>
+                  </a:txBody>
+                  <a:tcPr/>
+                </a:tc>
+              </a:tr>
+            </a:tbl>
+          </a:graphicData>
+        </a:graphic>
+      </p:graphicFrame>
+      <p:sp>
+        <p:nvSpPr>
+          <p:cNvPr id="5" name="TextBox 4"/>
           <p:cNvSpPr txBox="1"/>
           <p:nvPr/>
         </p:nvSpPr>
         <p:spPr>
           <a:xfrm>
-            <a:off x="548640" y="1463040"/>
-            <a:ext cx="11064240" cy="4937760"/>
+            <a:off x="457200" y="4114800"/>
+            <a:ext cx="11247120" cy="5394960"/>
           </a:xfrm>
           <a:prstGeom prst="rect">
             <a:avLst/>
@@ -3598,14 +4168,22 @@
               <a:spcAft>
                 <a:spcPts val="800"/>
               </a:spcAft>
-              <a:defRPr sz="1800" b="1">
+            </a:pPr>
+            <a:r>
+              <a:rPr sz="1200" b="1">
+                <a:solidFill>
+                  <a:srgbClr val="1F4E79"/>
+                </a:solidFill>
+              </a:rPr>
+              <a:t>Model</a:t>
+            </a:r>
+            <a:r>
+              <a:rPr sz="1200">
                 <a:solidFill>
                   <a:srgbClr val="222222"/>
                 </a:solidFill>
-              </a:defRPr>
-            </a:pPr>
-            <a:r>
-              <a:t>Moving home dominates: 82% of all terminations are 'Moving Home / Going Away' — largely uncontrollable churn</a:t>
+              </a:rPr>
+              <a:t>  —  stratified 20% holdout, one-hot encoded factors; logistic regression chosen for interpretability (odds ratios).</a:t>
             </a:r>
           </a:p>
           <a:p>
@@ -3613,14 +4191,22 @@
               <a:spcAft>
                 <a:spcPts val="800"/>
               </a:spcAft>
-              <a:defRPr sz="1800" b="0">
+            </a:pPr>
+            <a:r>
+              <a:rPr sz="1200" b="1">
+                <a:solidFill>
+                  <a:srgbClr val="1F4E79"/>
+                </a:solidFill>
+              </a:rPr>
+              <a:t>Strongest signals</a:t>
+            </a:r>
+            <a:r>
+              <a:rPr sz="1200">
                 <a:solidFill>
                   <a:srgbClr val="222222"/>
                 </a:solidFill>
-              </a:defRPr>
-            </a:pPr>
-            <a:r>
-              <a:t>Contract length is the strongest retention lever: 24-month contracts churn at 42.5% vs ~75% for monthly/12-month</a:t>
+              </a:rPr>
+              <a:t>  —  contract length (24m OR 0.22 vs 12m), cohort (2024 OR 0.09 — part exposure-window effect), Manchester vs Leeds (OR 1.51), 50Mb bundle (OR 1.39).</a:t>
             </a:r>
           </a:p>
           <a:p>
@@ -3628,14 +4214,22 @@
               <a:spcAft>
                 <a:spcPts val="800"/>
               </a:spcAft>
-              <a:defRPr sz="1800" b="0">
+            </a:pPr>
+            <a:r>
+              <a:rPr sz="1200" b="1">
+                <a:solidFill>
+                  <a:srgbClr val="1F4E79"/>
+                </a:solidFill>
+              </a:rPr>
+              <a:t>Not significant</a:t>
+            </a:r>
+            <a:r>
+              <a:rPr sz="1200">
                 <a:solidFill>
                   <a:srgbClr val="222222"/>
                 </a:solidFill>
-              </a:defRPr>
-            </a:pPr>
-            <a:r>
-              <a:t>Geography matters: Leeds (82%) and Manchester (77%) churn far above London (63%) and Nottingham (41%)</a:t>
+              </a:rPr>
+              <a:t>  —  number of competitors (p = 0.13 / 0.72) and London vs Leeds (p = 0.08) carry no signal once other factors are controlled.</a:t>
             </a:r>
           </a:p>
           <a:p>
@@ -3643,44 +4237,22 @@
               <a:spcAft>
                 <a:spcPts val="800"/>
               </a:spcAft>
-              <a:defRPr sz="1800" b="0">
+            </a:pPr>
+            <a:r>
+              <a:rPr sz="1200" b="1">
+                <a:solidFill>
+                  <a:srgbClr val="1F4E79"/>
+                </a:solidFill>
+              </a:rPr>
+              <a:t>Caveat</a:t>
+            </a:r>
+            <a:r>
+              <a:rPr sz="1200">
                 <a:solidFill>
                   <a:srgbClr val="222222"/>
                 </a:solidFill>
-              </a:defRPr>
-            </a:pPr>
-            <a:r>
-              <a:t>Entry-level 50Mb bundles churn most (82%); churn declines as speed rises — 1Gb at 66%</a:t>
-            </a:r>
-          </a:p>
-          <a:p>
-            <a:pPr>
-              <a:spcAft>
-                <a:spcPts val="800"/>
-              </a:spcAft>
-              <a:defRPr sz="1800" b="0">
-                <a:solidFill>
-                  <a:srgbClr val="222222"/>
-                </a:solidFill>
-              </a:defRPr>
-            </a:pPr>
-            <a:r>
-              <a:t>Controllable churn is small: price/deal (1.3%), complaints (0.5%), bad debt (5.5%)</a:t>
-            </a:r>
-          </a:p>
-          <a:p>
-            <a:pPr>
-              <a:spcAft>
-                <a:spcPts val="800"/>
-              </a:spcAft>
-              <a:defRPr sz="1800" b="0">
-                <a:solidFill>
-                  <a:srgbClr val="222222"/>
-                </a:solidFill>
-              </a:defRPr>
-            </a:pPr>
-            <a:r>
-              <a:t>Churned customers leave after a median of ~12 months — the contract-end cliff</a:t>
+              </a:rPr>
+              <a:t>  —  2023–24 cohort coefficients partly reflect shorter observation windows, not better retention — flagged by the no-year robustness model (AUC 0.64).</a:t>
             </a:r>
           </a:p>
         </p:txBody>
@@ -3711,8 +4283,8 @@
         </p:nvSpPr>
         <p:spPr>
           <a:xfrm>
-            <a:off x="457200" y="274320"/>
-            <a:ext cx="11247120" cy="822960"/>
+            <a:off x="457200" y="228600"/>
+            <a:ext cx="11247120" cy="640080"/>
           </a:xfrm>
           <a:prstGeom prst="rect">
             <a:avLst/>
@@ -3726,14 +4298,14 @@
           <a:lstStyle/>
           <a:p>
             <a:pPr>
-              <a:defRPr sz="3000" b="1">
+              <a:defRPr sz="2800" b="1">
                 <a:solidFill>
                   <a:srgbClr val="1F4E79"/>
                 </a:solidFill>
               </a:defRPr>
             </a:pPr>
             <a:r>
-              <a:t>Why Customers Leave</a:t>
+              <a:t>Prescriptive analysis — what to do about it</a:t>
             </a:r>
           </a:p>
         </p:txBody>
@@ -3746,8 +4318,8 @@
         </p:nvSpPr>
         <p:spPr>
           <a:xfrm>
-            <a:off x="457200" y="960120"/>
-            <a:ext cx="11247120" cy="457200"/>
+            <a:off x="457200" y="1005840"/>
+            <a:ext cx="11247120" cy="5394960"/>
           </a:xfrm>
           <a:prstGeom prst="rect">
             <a:avLst/>
@@ -3755,65 +4327,6 @@
           <a:noFill/>
         </p:spPr>
         <p:txBody>
-          <a:bodyPr wrap="none">
-            <a:spAutoFit/>
-          </a:bodyPr>
-          <a:lstStyle/>
-          <a:p>
-            <a:pPr>
-              <a:defRPr sz="1500">
-                <a:solidFill>
-                  <a:srgbClr val="222222"/>
-                </a:solidFill>
-              </a:defRPr>
-            </a:pPr>
-            <a:r>
-              <a:t>Termination reason distribution (6,947 churned customers)</a:t>
-            </a:r>
-          </a:p>
-        </p:txBody>
-      </p:sp>
-      <p:pic>
-        <p:nvPicPr>
-          <p:cNvPr id="4" name="Picture 3" descr="termination_reasons.png"/>
-          <p:cNvPicPr>
-            <a:picLocks noChangeAspect="1"/>
-          </p:cNvPicPr>
-          <p:nvPr/>
-        </p:nvPicPr>
-        <p:blipFill>
-          <a:blip r:embed="rId2"/>
-          <a:stretch>
-            <a:fillRect/>
-          </a:stretch>
-        </p:blipFill>
-        <p:spPr>
-          <a:xfrm>
-            <a:off x="548640" y="1371600"/>
-            <a:ext cx="6583680" cy="3511296"/>
-          </a:xfrm>
-          <a:prstGeom prst="rect">
-            <a:avLst/>
-          </a:prstGeom>
-        </p:spPr>
-      </p:pic>
-      <p:sp>
-        <p:nvSpPr>
-          <p:cNvPr id="5" name="TextBox 4"/>
-          <p:cNvSpPr txBox="1"/>
-          <p:nvPr/>
-        </p:nvSpPr>
-        <p:spPr>
-          <a:xfrm>
-            <a:off x="7406640" y="1554480"/>
-            <a:ext cx="4297680" cy="4937760"/>
-          </a:xfrm>
-          <a:prstGeom prst="rect">
-            <a:avLst/>
-          </a:prstGeom>
-          <a:noFill/>
-        </p:spPr>
-        <p:txBody>
           <a:bodyPr wrap="square">
             <a:spAutoFit/>
           </a:bodyPr>
@@ -3823,29 +4336,22 @@
               <a:spcAft>
                 <a:spcPts val="800"/>
               </a:spcAft>
-              <a:defRPr sz="1500" b="1">
+            </a:pPr>
+            <a:r>
+              <a:rPr sz="1500" b="1">
+                <a:solidFill>
+                  <a:srgbClr val="1F4E79"/>
+                </a:solidFill>
+              </a:rPr>
+              <a:t>1. Contract migration</a:t>
+            </a:r>
+            <a:r>
+              <a:rPr sz="1500">
                 <a:solidFill>
                   <a:srgbClr val="222222"/>
                 </a:solidFill>
-              </a:defRPr>
-            </a:pPr>
-            <a:r>
-              <a:t>'Moving Home/Going Away' = 82% of churn</a:t>
-            </a:r>
-          </a:p>
-          <a:p>
-            <a:pPr lvl="1">
-              <a:spcAft>
-                <a:spcPts val="800"/>
-              </a:spcAft>
-              <a:defRPr sz="1300" b="0">
-                <a:solidFill>
-                  <a:srgbClr val="222222"/>
-                </a:solidFill>
-              </a:defRPr>
-            </a:pPr>
-            <a:r>
-              <a:t>Fibre is address-bound: movers churn when the new home isn't served (no offnet product)</a:t>
+              </a:rPr>
+              <a:t>  —  move monthly/12-month customers toward 24-month terms near renewal — the single largest controllable effect (OR 0.22). Estimated addressable churn pool: ~60% of the base.</a:t>
             </a:r>
           </a:p>
           <a:p>
@@ -3853,14 +4359,22 @@
               <a:spcAft>
                 <a:spcPts val="800"/>
               </a:spcAft>
-              <a:defRPr sz="1500" b="0">
+            </a:pPr>
+            <a:r>
+              <a:rPr sz="1500" b="1">
+                <a:solidFill>
+                  <a:srgbClr val="1F4E79"/>
+                </a:solidFill>
+              </a:rPr>
+              <a:t>2. Mover's programme</a:t>
+            </a:r>
+            <a:r>
+              <a:rPr sz="1500">
                 <a:solidFill>
                   <a:srgbClr val="222222"/>
                 </a:solidFill>
-              </a:defRPr>
-            </a:pPr>
-            <a:r>
-              <a:t>'Customer not leaving' (521) likely admin/revoked terminations — data-quality fix</a:t>
+              </a:rPr>
+              <a:t>  —  82% of churn is relocation. Offer seamless home-move transfers and partner with landlords/developers so 'Moving Home' doesn't mean leaving.</a:t>
             </a:r>
           </a:p>
           <a:p>
@@ -3868,14 +4382,68 @@
               <a:spcAft>
                 <a:spcPts val="800"/>
               </a:spcAft>
-              <a:defRPr sz="1500" b="0">
+            </a:pPr>
+            <a:r>
+              <a:rPr sz="1500" b="1">
+                <a:solidFill>
+                  <a:srgbClr val="1F4E79"/>
+                </a:solidFill>
+              </a:rPr>
+              <a:t>3. Manchester &amp; Leeds focus</a:t>
+            </a:r>
+            <a:r>
+              <a:rPr sz="1500">
                 <a:solidFill>
                   <a:srgbClr val="222222"/>
                 </a:solidFill>
-              </a:defRPr>
+              </a:rPr>
+              <a:t>  —  highest churn rates and sizeable populations — investigate local service quality, installation experience and altnet overbuild pressure.</a:t>
+            </a:r>
+          </a:p>
+          <a:p>
+            <a:pPr>
+              <a:spcAft>
+                <a:spcPts val="800"/>
+              </a:spcAft>
             </a:pPr>
             <a:r>
-              <a:t>True controllable churn (price, complaints) is only ~2%</a:t>
+              <a:rPr sz="1500" b="1">
+                <a:solidFill>
+                  <a:srgbClr val="1F4E79"/>
+                </a:solidFill>
+              </a:rPr>
+              <a:t>4. 50Mb entry bundle</a:t>
+            </a:r>
+            <a:r>
+              <a:rPr sz="1500">
+                <a:solidFill>
+                  <a:srgbClr val="222222"/>
+                </a:solidFill>
+              </a:rPr>
+              <a:t>  —  highest bundle churn (82%, n=1,030) — entry-tier customers may be price-sensitive or underserved; consider upgrade paths.</a:t>
+            </a:r>
+          </a:p>
+          <a:p>
+            <a:pPr>
+              <a:spcAft>
+                <a:spcPts val="800"/>
+              </a:spcAft>
+            </a:pPr>
+            <a:r>
+              <a:rPr sz="1500" b="1">
+                <a:solidFill>
+                  <a:srgbClr val="1F4E79"/>
+                </a:solidFill>
+              </a:rPr>
+              <a:t>5. Early-tenure guardrail</a:t>
+            </a:r>
+            <a:r>
+              <a:rPr sz="1500">
+                <a:solidFill>
+                  <a:srgbClr val="222222"/>
+                </a:solidFill>
+              </a:rPr>
+              <a:t>  —  the 0–6-month group shows 100% recorded churn — an observation-window artifact, but real early churn exists (~1,070 customers); tighten onboarding and install experience.</a:t>
             </a:r>
           </a:p>
         </p:txBody>
@@ -3906,8 +4474,8 @@
         </p:nvSpPr>
         <p:spPr>
           <a:xfrm>
-            <a:off x="457200" y="274320"/>
-            <a:ext cx="11247120" cy="822960"/>
+            <a:off x="457200" y="228600"/>
+            <a:ext cx="11247120" cy="640080"/>
           </a:xfrm>
           <a:prstGeom prst="rect">
             <a:avLst/>
@@ -3921,14 +4489,14 @@
           <a:lstStyle/>
           <a:p>
             <a:pPr>
-              <a:defRPr sz="3000" b="1">
+              <a:defRPr sz="2800" b="1">
                 <a:solidFill>
                   <a:srgbClr val="1F4E79"/>
                 </a:solidFill>
               </a:defRPr>
             </a:pPr>
             <a:r>
-              <a:t>Contract Length &amp; Competition</a:t>
+              <a:t>Insights, recommendations &amp; caveats</a:t>
             </a:r>
           </a:p>
         </p:txBody>
@@ -3941,8 +4509,8 @@
         </p:nvSpPr>
         <p:spPr>
           <a:xfrm>
-            <a:off x="457200" y="960120"/>
-            <a:ext cx="11247120" cy="457200"/>
+            <a:off x="457200" y="1005840"/>
+            <a:ext cx="11247120" cy="5394960"/>
           </a:xfrm>
           <a:prstGeom prst="rect">
             <a:avLst/>
@@ -3950,89 +4518,6 @@
           <a:noFill/>
         </p:spPr>
         <p:txBody>
-          <a:bodyPr wrap="none">
-            <a:spAutoFit/>
-          </a:bodyPr>
-          <a:lstStyle/>
-          <a:p>
-            <a:pPr>
-              <a:defRPr sz="1500">
-                <a:solidFill>
-                  <a:srgbClr val="222222"/>
-                </a:solidFill>
-              </a:defRPr>
-            </a:pPr>
-            <a:r>
-              <a:t>Longer contracts retain; competitor presence shows a mild effect</a:t>
-            </a:r>
-          </a:p>
-        </p:txBody>
-      </p:sp>
-      <p:pic>
-        <p:nvPicPr>
-          <p:cNvPr id="4" name="Picture 3" descr="churn_by_contract.png"/>
-          <p:cNvPicPr>
-            <a:picLocks noChangeAspect="1"/>
-          </p:cNvPicPr>
-          <p:nvPr/>
-        </p:nvPicPr>
-        <p:blipFill>
-          <a:blip r:embed="rId2"/>
-          <a:stretch>
-            <a:fillRect/>
-          </a:stretch>
-        </p:blipFill>
-        <p:spPr>
-          <a:xfrm>
-            <a:off x="365760" y="1463040"/>
-            <a:ext cx="5394960" cy="3596640"/>
-          </a:xfrm>
-          <a:prstGeom prst="rect">
-            <a:avLst/>
-          </a:prstGeom>
-        </p:spPr>
-      </p:pic>
-      <p:pic>
-        <p:nvPicPr>
-          <p:cNvPr id="5" name="Picture 4" descr="churn_by_competitors.png"/>
-          <p:cNvPicPr>
-            <a:picLocks noChangeAspect="1"/>
-          </p:cNvPicPr>
-          <p:nvPr/>
-        </p:nvPicPr>
-        <p:blipFill>
-          <a:blip r:embed="rId3"/>
-          <a:stretch>
-            <a:fillRect/>
-          </a:stretch>
-        </p:blipFill>
-        <p:spPr>
-          <a:xfrm>
-            <a:off x="6309360" y="1463040"/>
-            <a:ext cx="5394960" cy="3596640"/>
-          </a:xfrm>
-          <a:prstGeom prst="rect">
-            <a:avLst/>
-          </a:prstGeom>
-        </p:spPr>
-      </p:pic>
-      <p:sp>
-        <p:nvSpPr>
-          <p:cNvPr id="6" name="TextBox 5"/>
-          <p:cNvSpPr txBox="1"/>
-          <p:nvPr/>
-        </p:nvSpPr>
-        <p:spPr>
-          <a:xfrm>
-            <a:off x="548640" y="5577840"/>
-            <a:ext cx="11064240" cy="1097280"/>
-          </a:xfrm>
-          <a:prstGeom prst="rect">
-            <a:avLst/>
-          </a:prstGeom>
-          <a:noFill/>
-        </p:spPr>
-        <p:txBody>
           <a:bodyPr wrap="square">
             <a:spAutoFit/>
           </a:bodyPr>
@@ -4042,14 +4527,22 @@
               <a:spcAft>
                 <a:spcPts val="800"/>
               </a:spcAft>
-              <a:defRPr sz="1400" b="1">
+            </a:pPr>
+            <a:r>
+              <a:rPr sz="1500" b="1">
+                <a:solidFill>
+                  <a:srgbClr val="1F4E79"/>
+                </a:solidFill>
+              </a:rPr>
+              <a:t>Insight</a:t>
+            </a:r>
+            <a:r>
+              <a:rPr sz="1500">
                 <a:solidFill>
                   <a:srgbClr val="222222"/>
                 </a:solidFill>
-              </a:defRPr>
-            </a:pPr>
-            <a:r>
-              <a:t>24-month contracts cut churn nearly in half vs monthly rolling</a:t>
+              </a:rPr>
+              <a:t>  —  churn in this dataset is dominated by structural movers and contract structure — price/competition play a minor recorded role (competitors V = 0.03).</a:t>
             </a:r>
           </a:p>
           <a:p>
@@ -4057,153 +4550,45 @@
               <a:spcAft>
                 <a:spcPts val="800"/>
               </a:spcAft>
-              <a:defRPr sz="1400" b="0">
+            </a:pPr>
+            <a:r>
+              <a:rPr sz="1500" b="1">
+                <a:solidFill>
+                  <a:srgbClr val="1F4E79"/>
+                </a:solidFill>
+              </a:rPr>
+              <a:t>Recommendation 1</a:t>
+            </a:r>
+            <a:r>
+              <a:rPr sz="1500">
                 <a:solidFill>
                   <a:srgbClr val="222222"/>
                 </a:solidFill>
-              </a:defRPr>
-            </a:pPr>
-            <a:r>
-              <a:t>Areas with 1+ competitors churn ~4pts more than uncontested areas; 2-competitor sample is tiny (n=40)</a:t>
-            </a:r>
-          </a:p>
-        </p:txBody>
-      </p:sp>
-    </p:spTree>
-  </p:cSld>
-  <p:clrMapOvr>
-    <a:masterClrMapping/>
-  </p:clrMapOvr>
-</p:sld>
-</file>
-
-<file path=ppt/slides/slide6.xml><?xml version="1.0" encoding="utf-8"?>
-<p:sld xmlns:a="http://schemas.openxmlformats.org/drawingml/2006/main" xmlns:p="http://schemas.openxmlformats.org/presentationml/2006/main" xmlns:r="http://schemas.openxmlformats.org/officeDocument/2006/relationships">
-  <p:cSld>
-    <p:spTree>
-      <p:nvGrpSpPr>
-        <p:cNvPr id="1" name=""/>
-        <p:cNvGrpSpPr/>
-        <p:nvPr/>
-      </p:nvGrpSpPr>
-      <p:grpSpPr/>
-      <p:sp>
-        <p:nvSpPr>
-          <p:cNvPr id="2" name="TextBox 1"/>
-          <p:cNvSpPr txBox="1"/>
-          <p:nvPr/>
-        </p:nvSpPr>
-        <p:spPr>
-          <a:xfrm>
-            <a:off x="457200" y="274320"/>
-            <a:ext cx="11247120" cy="822960"/>
-          </a:xfrm>
-          <a:prstGeom prst="rect">
-            <a:avLst/>
-          </a:prstGeom>
-          <a:noFill/>
-        </p:spPr>
-        <p:txBody>
-          <a:bodyPr wrap="none">
-            <a:spAutoFit/>
-          </a:bodyPr>
-          <a:lstStyle/>
-          <a:p>
-            <a:pPr>
-              <a:defRPr sz="3000" b="1">
-                <a:solidFill>
-                  <a:srgbClr val="1F4E79"/>
-                </a:solidFill>
-              </a:defRPr>
-            </a:pPr>
-            <a:r>
-              <a:t>Where and What: Geography &amp; Bundle</a:t>
-            </a:r>
-          </a:p>
-        </p:txBody>
-      </p:sp>
-      <p:pic>
-        <p:nvPicPr>
-          <p:cNvPr id="3" name="Picture 2" descr="churn_by_city.png"/>
-          <p:cNvPicPr>
-            <a:picLocks noChangeAspect="1"/>
-          </p:cNvPicPr>
-          <p:nvPr/>
-        </p:nvPicPr>
-        <p:blipFill>
-          <a:blip r:embed="rId2"/>
-          <a:stretch>
-            <a:fillRect/>
-          </a:stretch>
-        </p:blipFill>
-        <p:spPr>
-          <a:xfrm>
-            <a:off x="365760" y="1463040"/>
-            <a:ext cx="5394960" cy="3596640"/>
-          </a:xfrm>
-          <a:prstGeom prst="rect">
-            <a:avLst/>
-          </a:prstGeom>
-        </p:spPr>
-      </p:pic>
-      <p:pic>
-        <p:nvPicPr>
-          <p:cNvPr id="4" name="Picture 3" descr="churn_by_bundle.png"/>
-          <p:cNvPicPr>
-            <a:picLocks noChangeAspect="1"/>
-          </p:cNvPicPr>
-          <p:nvPr/>
-        </p:nvPicPr>
-        <p:blipFill>
-          <a:blip r:embed="rId3"/>
-          <a:stretch>
-            <a:fillRect/>
-          </a:stretch>
-        </p:blipFill>
-        <p:spPr>
-          <a:xfrm>
-            <a:off x="6309360" y="1463040"/>
-            <a:ext cx="5486400" cy="3135086"/>
-          </a:xfrm>
-          <a:prstGeom prst="rect">
-            <a:avLst/>
-          </a:prstGeom>
-        </p:spPr>
-      </p:pic>
-      <p:sp>
-        <p:nvSpPr>
-          <p:cNvPr id="5" name="TextBox 4"/>
-          <p:cNvSpPr txBox="1"/>
-          <p:nvPr/>
-        </p:nvSpPr>
-        <p:spPr>
-          <a:xfrm>
-            <a:off x="548640" y="5577840"/>
-            <a:ext cx="11064240" cy="1097280"/>
-          </a:xfrm>
-          <a:prstGeom prst="rect">
-            <a:avLst/>
-          </a:prstGeom>
-          <a:noFill/>
-        </p:spPr>
-        <p:txBody>
-          <a:bodyPr wrap="square">
-            <a:spAutoFit/>
-          </a:bodyPr>
-          <a:lstStyle/>
+              </a:rPr>
+              <a:t>  —  deploy the model into CRM: score active customers (the Flask app already exposes per-profile churn probability) and trigger retention offers above a threshold.</a:t>
+            </a:r>
+          </a:p>
           <a:p>
             <a:pPr>
               <a:spcAft>
                 <a:spcPts val="800"/>
               </a:spcAft>
-              <a:defRPr sz="1400" b="0">
+            </a:pPr>
+            <a:r>
+              <a:rPr sz="1500" b="1">
+                <a:solidFill>
+                  <a:srgbClr val="1F4E79"/>
+                </a:solidFill>
+              </a:rPr>
+              <a:t>Recommendation 2</a:t>
+            </a:r>
+            <a:r>
+              <a:rPr sz="1500">
                 <a:solidFill>
                   <a:srgbClr val="222222"/>
                 </a:solidFill>
-              </a:defRPr>
-            </a:pPr>
-            <a:r>
-              <a:t>Leeds &amp; Manchester churn ~15-20pts above London — likely higher overbuild/competition and housing churn</a:t>
+              </a:rPr>
+              <a:t>  —  report churn on a survival/exposure basis — raw cohort rates overstate recent-cohort improvement.</a:t>
             </a:r>
           </a:p>
           <a:p>
@@ -4211,630 +4596,45 @@
               <a:spcAft>
                 <a:spcPts val="800"/>
               </a:spcAft>
-              <a:defRPr sz="1400" b="0">
+            </a:pPr>
+            <a:r>
+              <a:rPr sz="1500" b="1">
+                <a:solidFill>
+                  <a:srgbClr val="1F4E79"/>
+                </a:solidFill>
+              </a:rPr>
+              <a:t>Recommendation 3</a:t>
+            </a:r>
+            <a:r>
+              <a:rPr sz="1500">
                 <a:solidFill>
                   <a:srgbClr val="222222"/>
                 </a:solidFill>
-              </a:defRPr>
-            </a:pPr>
-            <a:r>
-              <a:t>50Mb entry tier churns most — entry-tier customers are the most price-sensitive and mobile</a:t>
-            </a:r>
-          </a:p>
-        </p:txBody>
-      </p:sp>
-    </p:spTree>
-  </p:cSld>
-  <p:clrMapOvr>
-    <a:masterClrMapping/>
-  </p:clrMapOvr>
-</p:sld>
-</file>
-
-<file path=ppt/slides/slide7.xml><?xml version="1.0" encoding="utf-8"?>
-<p:sld xmlns:a="http://schemas.openxmlformats.org/drawingml/2006/main" xmlns:p="http://schemas.openxmlformats.org/presentationml/2006/main" xmlns:r="http://schemas.openxmlformats.org/officeDocument/2006/relationships">
-  <p:cSld>
-    <p:spTree>
-      <p:nvGrpSpPr>
-        <p:cNvPr id="1" name=""/>
-        <p:cNvGrpSpPr/>
-        <p:nvPr/>
-      </p:nvGrpSpPr>
-      <p:grpSpPr/>
-      <p:sp>
-        <p:nvSpPr>
-          <p:cNvPr id="2" name="TextBox 1"/>
-          <p:cNvSpPr txBox="1"/>
-          <p:nvPr/>
-        </p:nvSpPr>
-        <p:spPr>
-          <a:xfrm>
-            <a:off x="457200" y="274320"/>
-            <a:ext cx="11247120" cy="822960"/>
-          </a:xfrm>
-          <a:prstGeom prst="rect">
-            <a:avLst/>
-          </a:prstGeom>
-          <a:noFill/>
-        </p:spPr>
-        <p:txBody>
-          <a:bodyPr wrap="none">
-            <a:spAutoFit/>
-          </a:bodyPr>
-          <a:lstStyle/>
-          <a:p>
-            <a:pPr>
-              <a:defRPr sz="3000" b="1">
-                <a:solidFill>
-                  <a:srgbClr val="1F4E79"/>
-                </a:solidFill>
-              </a:defRPr>
-            </a:pPr>
-            <a:r>
-              <a:t>When Customers Leave</a:t>
-            </a:r>
-          </a:p>
-        </p:txBody>
-      </p:sp>
-      <p:sp>
-        <p:nvSpPr>
-          <p:cNvPr id="3" name="TextBox 2"/>
-          <p:cNvSpPr txBox="1"/>
-          <p:nvPr/>
-        </p:nvSpPr>
-        <p:spPr>
-          <a:xfrm>
-            <a:off x="457200" y="960120"/>
-            <a:ext cx="11247120" cy="457200"/>
-          </a:xfrm>
-          <a:prstGeom prst="rect">
-            <a:avLst/>
-          </a:prstGeom>
-          <a:noFill/>
-        </p:spPr>
-        <p:txBody>
-          <a:bodyPr wrap="none">
-            <a:spAutoFit/>
-          </a:bodyPr>
-          <a:lstStyle/>
-          <a:p>
-            <a:pPr>
-              <a:defRPr sz="1500">
-                <a:solidFill>
-                  <a:srgbClr val="222222"/>
-                </a:solidFill>
-              </a:defRPr>
-            </a:pPr>
-            <a:r>
-              <a:t>Median churned tenure ~12 months — churn concentrates at contract end</a:t>
-            </a:r>
-          </a:p>
-        </p:txBody>
-      </p:sp>
-      <p:pic>
-        <p:nvPicPr>
-          <p:cNvPr id="4" name="Picture 3" descr="tenure_hist.png"/>
-          <p:cNvPicPr>
-            <a:picLocks noChangeAspect="1"/>
-          </p:cNvPicPr>
-          <p:nvPr/>
-        </p:nvPicPr>
-        <p:blipFill>
-          <a:blip r:embed="rId2"/>
-          <a:stretch>
-            <a:fillRect/>
-          </a:stretch>
-        </p:blipFill>
-        <p:spPr>
-          <a:xfrm>
-            <a:off x="365760" y="1463040"/>
-            <a:ext cx="5486400" cy="3376246"/>
-          </a:xfrm>
-          <a:prstGeom prst="rect">
-            <a:avLst/>
-          </a:prstGeom>
-        </p:spPr>
-      </p:pic>
-      <p:pic>
-        <p:nvPicPr>
-          <p:cNvPr id="5" name="Picture 4" descr="churn_time.png"/>
-          <p:cNvPicPr>
-            <a:picLocks noChangeAspect="1"/>
-          </p:cNvPicPr>
-          <p:nvPr/>
-        </p:nvPicPr>
-        <p:blipFill>
-          <a:blip r:embed="rId3"/>
-          <a:stretch>
-            <a:fillRect/>
-          </a:stretch>
-        </p:blipFill>
-        <p:spPr>
-          <a:xfrm>
-            <a:off x="6217920" y="1463040"/>
-            <a:ext cx="5669280" cy="2061556"/>
-          </a:xfrm>
-          <a:prstGeom prst="rect">
-            <a:avLst/>
-          </a:prstGeom>
-        </p:spPr>
-      </p:pic>
-      <p:sp>
-        <p:nvSpPr>
-          <p:cNvPr id="6" name="TextBox 5"/>
-          <p:cNvSpPr txBox="1"/>
-          <p:nvPr/>
-        </p:nvSpPr>
-        <p:spPr>
-          <a:xfrm>
-            <a:off x="548640" y="5577840"/>
-            <a:ext cx="11064240" cy="1097280"/>
-          </a:xfrm>
-          <a:prstGeom prst="rect">
-            <a:avLst/>
-          </a:prstGeom>
-          <a:noFill/>
-        </p:spPr>
-        <p:txBody>
-          <a:bodyPr wrap="square">
-            <a:spAutoFit/>
-          </a:bodyPr>
-          <a:lstStyle/>
+              </a:rPr>
+              <a:t>  —  clarify the 'Customer not leaving' category (521 records, 7.5% of churn) — it records a termination date but ambiguous churn meaning.</a:t>
+            </a:r>
+          </a:p>
           <a:p>
             <a:pPr>
               <a:spcAft>
                 <a:spcPts val="800"/>
               </a:spcAft>
-              <a:defRPr sz="1400" b="0">
+            </a:pPr>
+            <a:r>
+              <a:rPr sz="1500" b="1">
+                <a:solidFill>
+                  <a:srgbClr val="1F4E79"/>
+                </a:solidFill>
+              </a:rPr>
+              <a:t>Caveat</a:t>
+            </a:r>
+            <a:r>
+              <a:rPr sz="1500">
                 <a:solidFill>
                   <a:srgbClr val="222222"/>
                 </a:solidFill>
-              </a:defRPr>
-            </a:pPr>
-            <a:r>
-              <a:t>Churn spikes around the 12-month mark — contract expiry and intro-price rollover are the trigger</a:t>
-            </a:r>
-          </a:p>
-          <a:p>
-            <a:pPr>
-              <a:spcAft>
-                <a:spcPts val="800"/>
-              </a:spcAft>
-              <a:defRPr sz="1400" b="0">
-                <a:solidFill>
-                  <a:srgbClr val="222222"/>
-                </a:solidFill>
-              </a:defRPr>
-            </a:pPr>
-            <a:r>
-              <a:t>7.4% of churn happens within 3 months — early-life onboarding/installation issues</a:t>
-            </a:r>
-          </a:p>
-        </p:txBody>
-      </p:sp>
-    </p:spTree>
-  </p:cSld>
-  <p:clrMapOvr>
-    <a:masterClrMapping/>
-  </p:clrMapOvr>
-</p:sld>
-</file>
-
-<file path=ppt/slides/slide8.xml><?xml version="1.0" encoding="utf-8"?>
-<p:sld xmlns:a="http://schemas.openxmlformats.org/drawingml/2006/main" xmlns:p="http://schemas.openxmlformats.org/presentationml/2006/main" xmlns:r="http://schemas.openxmlformats.org/officeDocument/2006/relationships">
-  <p:cSld>
-    <p:spTree>
-      <p:nvGrpSpPr>
-        <p:cNvPr id="1" name=""/>
-        <p:cNvGrpSpPr/>
-        <p:nvPr/>
-      </p:nvGrpSpPr>
-      <p:grpSpPr/>
-      <p:sp>
-        <p:nvSpPr>
-          <p:cNvPr id="2" name="TextBox 1"/>
-          <p:cNvSpPr txBox="1"/>
-          <p:nvPr/>
-        </p:nvSpPr>
-        <p:spPr>
-          <a:xfrm>
-            <a:off x="457200" y="274320"/>
-            <a:ext cx="11247120" cy="822960"/>
-          </a:xfrm>
-          <a:prstGeom prst="rect">
-            <a:avLst/>
-          </a:prstGeom>
-          <a:noFill/>
-        </p:spPr>
-        <p:txBody>
-          <a:bodyPr wrap="none">
-            <a:spAutoFit/>
-          </a:bodyPr>
-          <a:lstStyle/>
-          <a:p>
-            <a:pPr>
-              <a:defRPr sz="3000" b="1">
-                <a:solidFill>
-                  <a:srgbClr val="1F4E79"/>
-                </a:solidFill>
-              </a:defRPr>
-            </a:pPr>
-            <a:r>
-              <a:t>UK Fibre Market Context</a:t>
-            </a:r>
-          </a:p>
-        </p:txBody>
-      </p:sp>
-      <p:sp>
-        <p:nvSpPr>
-          <p:cNvPr id="3" name="TextBox 2"/>
-          <p:cNvSpPr txBox="1"/>
-          <p:nvPr/>
-        </p:nvSpPr>
-        <p:spPr>
-          <a:xfrm>
-            <a:off x="457200" y="960120"/>
-            <a:ext cx="11247120" cy="457200"/>
-          </a:xfrm>
-          <a:prstGeom prst="rect">
-            <a:avLst/>
-          </a:prstGeom>
-          <a:noFill/>
-        </p:spPr>
-        <p:txBody>
-          <a:bodyPr wrap="none">
-            <a:spAutoFit/>
-          </a:bodyPr>
-          <a:lstStyle/>
-          <a:p>
-            <a:pPr>
-              <a:defRPr sz="1500">
-                <a:solidFill>
-                  <a:srgbClr val="222222"/>
-                </a:solidFill>
-              </a:defRPr>
-            </a:pPr>
-            <a:r>
-              <a:t>External factors that amplify the findings</a:t>
-            </a:r>
-          </a:p>
-        </p:txBody>
-      </p:sp>
-      <p:sp>
-        <p:nvSpPr>
-          <p:cNvPr id="4" name="TextBox 3"/>
-          <p:cNvSpPr txBox="1"/>
-          <p:nvPr/>
-        </p:nvSpPr>
-        <p:spPr>
-          <a:xfrm>
-            <a:off x="548640" y="1463040"/>
-            <a:ext cx="11064240" cy="4937760"/>
-          </a:xfrm>
-          <a:prstGeom prst="rect">
-            <a:avLst/>
-          </a:prstGeom>
-          <a:noFill/>
-        </p:spPr>
-        <p:txBody>
-          <a:bodyPr wrap="square">
-            <a:spAutoFit/>
-          </a:bodyPr>
-          <a:lstStyle/>
-          <a:p>
-            <a:pPr>
-              <a:spcAft>
-                <a:spcPts val="800"/>
-              </a:spcAft>
-              <a:defRPr sz="1800" b="0">
-                <a:solidFill>
-                  <a:srgbClr val="222222"/>
-                </a:solidFill>
-              </a:defRPr>
-            </a:pPr>
-            <a:r>
-              <a:t>Altnet footprint nearly doubled: ~16m premises passed by late 2025 (~57% of UK FTTP) — overbuild keeps rising</a:t>
-            </a:r>
-          </a:p>
-          <a:p>
-            <a:pPr>
-              <a:spcAft>
-                <a:spcPts val="800"/>
-              </a:spcAft>
-              <a:defRPr sz="1800" b="0">
-                <a:solidFill>
-                  <a:srgbClr val="222222"/>
-                </a:solidFill>
-              </a:defRPr>
-            </a:pPr>
-            <a:r>
-              <a:t>FTTP prices fell ~41% in real terms over 3 years — switching is cheap and heavily promoted</a:t>
-            </a:r>
-          </a:p>
-          <a:p>
-            <a:pPr>
-              <a:spcAft>
-                <a:spcPts val="800"/>
-              </a:spcAft>
-              <a:defRPr sz="1800" b="0">
-                <a:solidFill>
-                  <a:srgbClr val="222222"/>
-                </a:solidFill>
-              </a:defRPr>
-            </a:pPr>
-            <a:r>
-              <a:t>House moves are the industry's largest 'uncontrollable' churn driver, worsened by Stamp-Duty-driven moves; most altnets don't sell offnet, so movers are lost at the address boundary</a:t>
-            </a:r>
-          </a:p>
-          <a:p>
-            <a:pPr>
-              <a:spcAft>
-                <a:spcPts val="800"/>
-              </a:spcAft>
-              <a:defRPr sz="1800" b="0">
-                <a:solidFill>
-                  <a:srgbClr val="222222"/>
-                </a:solidFill>
-              </a:defRPr>
-            </a:pPr>
-            <a:r>
-              <a:t>Consolidation is coming (CityFibre capital raise, Netomnia/nexfibre deal) — scale players will gain wholesale reach into the mover market</a:t>
-            </a:r>
-          </a:p>
-          <a:p>
-            <a:pPr>
-              <a:spcAft>
-                <a:spcPts val="800"/>
-              </a:spcAft>
-              <a:defRPr sz="1800" b="0">
-                <a:solidFill>
-                  <a:srgbClr val="222222"/>
-                </a:solidFill>
-              </a:defRPr>
-            </a:pPr>
-            <a:r>
-              <a:t>Altnets hold ~11% retail share; Hyperoptic ~1.7% — retention economics matter more than share grabs</a:t>
-            </a:r>
-          </a:p>
-          <a:p>
-            <a:pPr lvl="1">
-              <a:spcAft>
-                <a:spcPts val="800"/>
-              </a:spcAft>
-              <a:defRPr sz="1600" b="0">
-                <a:solidFill>
-                  <a:srgbClr val="222222"/>
-                </a:solidFill>
-              </a:defRPr>
-            </a:pPr>
-            <a:r>
-              <a:t>Sources: Intelligens Consulting (Dec 2025), 8Advisory FTTH take-up &amp; churn (Jul 2025), Opensignal (Q2 2026), Enders Analysis Q2 2025</a:t>
-            </a:r>
-          </a:p>
-        </p:txBody>
-      </p:sp>
-    </p:spTree>
-  </p:cSld>
-  <p:clrMapOvr>
-    <a:masterClrMapping/>
-  </p:clrMapOvr>
-</p:sld>
-</file>
-
-<file path=ppt/slides/slide9.xml><?xml version="1.0" encoding="utf-8"?>
-<p:sld xmlns:a="http://schemas.openxmlformats.org/drawingml/2006/main" xmlns:p="http://schemas.openxmlformats.org/presentationml/2006/main" xmlns:r="http://schemas.openxmlformats.org/officeDocument/2006/relationships">
-  <p:cSld>
-    <p:spTree>
-      <p:nvGrpSpPr>
-        <p:cNvPr id="1" name=""/>
-        <p:cNvGrpSpPr/>
-        <p:nvPr/>
-      </p:nvGrpSpPr>
-      <p:grpSpPr/>
-      <p:sp>
-        <p:nvSpPr>
-          <p:cNvPr id="2" name="TextBox 1"/>
-          <p:cNvSpPr txBox="1"/>
-          <p:nvPr/>
-        </p:nvSpPr>
-        <p:spPr>
-          <a:xfrm>
-            <a:off x="457200" y="274320"/>
-            <a:ext cx="11247120" cy="822960"/>
-          </a:xfrm>
-          <a:prstGeom prst="rect">
-            <a:avLst/>
-          </a:prstGeom>
-          <a:noFill/>
-        </p:spPr>
-        <p:txBody>
-          <a:bodyPr wrap="none">
-            <a:spAutoFit/>
-          </a:bodyPr>
-          <a:lstStyle/>
-          <a:p>
-            <a:pPr>
-              <a:defRPr sz="3000" b="1">
-                <a:solidFill>
-                  <a:srgbClr val="1F4E79"/>
-                </a:solidFill>
-              </a:defRPr>
-            </a:pPr>
-            <a:r>
-              <a:t>Recommendations</a:t>
-            </a:r>
-          </a:p>
-        </p:txBody>
-      </p:sp>
-      <p:sp>
-        <p:nvSpPr>
-          <p:cNvPr id="3" name="TextBox 2"/>
-          <p:cNvSpPr txBox="1"/>
-          <p:nvPr/>
-        </p:nvSpPr>
-        <p:spPr>
-          <a:xfrm>
-            <a:off x="548640" y="1463040"/>
-            <a:ext cx="11064240" cy="4937760"/>
-          </a:xfrm>
-          <a:prstGeom prst="rect">
-            <a:avLst/>
-          </a:prstGeom>
-          <a:noFill/>
-        </p:spPr>
-        <p:txBody>
-          <a:bodyPr wrap="square">
-            <a:spAutoFit/>
-          </a:bodyPr>
-          <a:lstStyle/>
-          <a:p>
-            <a:pPr>
-              <a:spcAft>
-                <a:spcPts val="800"/>
-              </a:spcAft>
-              <a:defRPr sz="1800" b="1">
-                <a:solidFill>
-                  <a:srgbClr val="222222"/>
-                </a:solidFill>
-              </a:defRPr>
-            </a:pPr>
-            <a:r>
-              <a:t>Attack the mover market (82% of churn)</a:t>
-            </a:r>
-          </a:p>
-          <a:p>
-            <a:pPr lvl="1">
-              <a:spcAft>
-                <a:spcPts val="800"/>
-              </a:spcAft>
-              <a:defRPr sz="1600" b="0">
-                <a:solidFill>
-                  <a:srgbClr val="222222"/>
-                </a:solidFill>
-              </a:defRPr>
-            </a:pPr>
-            <a:r>
-              <a:t>Launch a mover's program: proactive 'we're at your new address' outreach, address-portability check, partnered install at move-in</a:t>
-            </a:r>
-          </a:p>
-          <a:p>
-            <a:pPr lvl="1">
-              <a:spcAft>
-                <a:spcPts val="800"/>
-              </a:spcAft>
-              <a:defRPr sz="1600" b="0">
-                <a:solidFill>
-                  <a:srgbClr val="222222"/>
-                </a:solidFill>
-              </a:defRPr>
-            </a:pPr>
-            <a:r>
-              <a:t>Pursue wholesale/offnet partnerships (e.g. CityFibre, Openreach FTTP) so movers can stay customers at non-served addresses</a:t>
-            </a:r>
-          </a:p>
-          <a:p>
-            <a:pPr>
-              <a:spcAft>
-                <a:spcPts val="800"/>
-              </a:spcAft>
-              <a:defRPr sz="1800" b="1">
-                <a:solidFill>
-                  <a:srgbClr val="222222"/>
-                </a:solidFill>
-              </a:defRPr>
-            </a:pPr>
-            <a:r>
-              <a:t>Shift the base to longer contracts</a:t>
-            </a:r>
-          </a:p>
-          <a:p>
-            <a:pPr lvl="1">
-              <a:spcAft>
-                <a:spcPts val="800"/>
-              </a:spcAft>
-              <a:defRPr sz="1600" b="0">
-                <a:solidFill>
-                  <a:srgbClr val="222222"/>
-                </a:solidFill>
-              </a:defRPr>
-            </a:pPr>
-            <a:r>
-              <a:t>Incentivise 24-month terms (price locks, free speed upgrades) — they halve churn</a:t>
-            </a:r>
-          </a:p>
-          <a:p>
-            <a:pPr>
-              <a:spcAft>
-                <a:spcPts val="800"/>
-              </a:spcAft>
-              <a:defRPr sz="1800" b="1">
-                <a:solidFill>
-                  <a:srgbClr val="222222"/>
-                </a:solidFill>
-              </a:defRPr>
-            </a:pPr>
-            <a:r>
-              <a:t>Pre-empt the 12-month cliff</a:t>
-            </a:r>
-          </a:p>
-          <a:p>
-            <a:pPr lvl="1">
-              <a:spcAft>
-                <a:spcPts val="800"/>
-              </a:spcAft>
-              <a:defRPr sz="1600" b="0">
-                <a:solidFill>
-                  <a:srgbClr val="222222"/>
-                </a:solidFill>
-              </a:defRPr>
-            </a:pPr>
-            <a:r>
-              <a:t>Retention offers 60-90 days before contract end; re-contract before intro pricing rolls off</a:t>
-            </a:r>
-          </a:p>
-          <a:p>
-            <a:pPr>
-              <a:spcAft>
-                <a:spcPts val="800"/>
-              </a:spcAft>
-              <a:defRPr sz="1800" b="0">
-                <a:solidFill>
-                  <a:srgbClr val="222222"/>
-                </a:solidFill>
-              </a:defRPr>
-            </a:pPr>
-            <a:r>
-              <a:t>Fix early-life churn: onboarding quality checks and 90-day save-desk for new installs</a:t>
-            </a:r>
-          </a:p>
-          <a:p>
-            <a:pPr>
-              <a:spcAft>
-                <a:spcPts val="800"/>
-              </a:spcAft>
-              <a:defRPr sz="1800" b="0">
-                <a:solidFill>
-                  <a:srgbClr val="222222"/>
-                </a:solidFill>
-              </a:defRPr>
-            </a:pPr>
-            <a:r>
-              <a:t>Regional playbook for Leeds/Manchester: competitive win-back offers and service-quality audits where overbuild is densest</a:t>
-            </a:r>
-          </a:p>
-          <a:p>
-            <a:pPr>
-              <a:spcAft>
-                <a:spcPts val="800"/>
-              </a:spcAft>
-              <a:defRPr sz="1800" b="0">
-                <a:solidFill>
-                  <a:srgbClr val="222222"/>
-                </a:solidFill>
-              </a:defRPr>
-            </a:pPr>
-            <a:r>
-              <a:t>Data hygiene: reconcile 'Customer not leaving' records and add mover destination capture to measure recoverable churn</a:t>
+              </a:rPr>
+              <a:t>  —  the dataset is churn-weighted (69.5% observed churn is not the live-business rate); model AUC 0.80 is good for ranking, probabilities need recalibration on live volumes.</a:t>
             </a:r>
           </a:p>
         </p:txBody>

</xml_diff>